<commit_message>
Keep English and French only; remove Gujarati
App language menu, AI answer languages, prototype, presentation,
documentation and READMEs now cover English and French.

Co-Authored-By: Claude Opus 5.5 <noreply@anthropic.com>
</commit_message>
<xml_diff>
--- a/presentation/TruthShift_Presentation.pptx
+++ b/presentation/TruthShift_Presentation.pptx
@@ -123,7 +123,7 @@
   <p:extLst>
     <p:ext uri="{521415D9-36F7-43E2-AB2F-B90AF26B5E84}">
       <p14:sectionLst xmlns:p14="http://schemas.microsoft.com/office/powerpoint/2010/main">
-        <p14:section name="Why" id="{43045a00-eb2d-a271-e319-b09a83d4364e}">
+        <p14:section name="Why" id="{1c19757a-9ba5-7c27-c035-7682ddb088bf}">
           <p14:sldIdLst>
             <p14:sldId id="256"/>
             <p14:sldId id="257"/>
@@ -131,38 +131,38 @@
             <p14:sldId id="259"/>
           </p14:sldIdLst>
         </p14:section>
-        <p14:section name="What it does" id="{74172564-1a51-2cc3-7421-867762f47375}">
+        <p14:section name="What it does" id="{8a0520d7-7c8c-61c6-05e2-7063c1cca5ab}">
           <p14:sldIdLst>
             <p14:sldId id="260"/>
             <p14:sldId id="261"/>
             <p14:sldId id="262"/>
           </p14:sldIdLst>
         </p14:section>
-        <p14:section name="Demo" id="{feaad919-5fb1-1137-b56b-5ddc04d03725}">
+        <p14:section name="Demo" id="{49bb6b26-2c9c-aba9-29b4-e6bd53750cdf}">
           <p14:sldIdLst>
             <p14:sldId id="263"/>
           </p14:sldIdLst>
         </p14:section>
-        <p14:section name="How it is built" id="{1d69ec8f-4ded-db7d-bab9-147c082e894e}">
+        <p14:section name="How it is built" id="{485f64da-2eea-6eec-5732-45305574c1bc}">
           <p14:sldIdLst>
             <p14:sldId id="264"/>
             <p14:sldId id="267"/>
           </p14:sldIdLst>
         </p14:section>
-        <p14:section name="Model" id="{b56dcb3c-0237-f2bb-f95e-ae872e417962}">
+        <p14:section name="Model" id="{0584153e-3c12-3692-d00d-cff22e2ca714}">
           <p14:sldIdLst>
             <p14:sldId id="265"/>
             <p14:sldId id="266"/>
           </p14:sldIdLst>
         </p14:section>
-        <p14:section name="Business model" id="{041acf1e-1d1c-7ecc-797c-6f60c29de0c3}">
+        <p14:section name="Business model" id="{6ca29899-0b31-16b8-3d35-b36a6fa7e48e}">
           <p14:sldIdLst>
             <p14:sldId id="268"/>
             <p14:sldId id="269"/>
             <p14:sldId id="270"/>
           </p14:sldIdLst>
         </p14:section>
-        <p14:section name="Next" id="{f876fefa-dfd9-ce7f-d97d-d6996311501b}">
+        <p14:section name="Next" id="{6db61215-8d6a-a367-b95f-6281565ceb9e}">
           <p14:sldIdLst>
             <p14:sldId id="271"/>
             <p14:sldId id="272"/>
@@ -2773,7 +2773,7 @@
           <a:p>
             <a:r>
               <a:rPr lang="en-US" dirty="0"/>
-              <a:t>RODS serves newcomers, so we designed for them. Their language: English, French and Gujarati screens, and the AI answers in the chosen language. Their budget: affordability is a priority like any other, and every better option shows the price difference. Their city: Regina stores on a map, local businesses, and Regina’s blue and green cart recycling rules.</a:t>
+              <a:t>RODS serves newcomers, so we designed for them. Their language: English and French screens, and the AI answers in the chosen language. Their budget: affordability is a priority like any other, and every better option shows the price difference. Their city: Regina stores on a map, local businesses, and Regina’s blue and green cart recycling rules.</a:t>
             </a:r>
             <a:endParaRPr lang="en-US" dirty="0"/>
           </a:p>
@@ -3125,7 +3125,7 @@
           <a:p>
             <a:r>
               <a:rPr lang="en-US" dirty="0"/>
-              <a:t>Demo script. 1: Priorities tab, Buy Canadian preset, switch language to Gujarati. 2: Scan tab, search peanut, open Prairie Creamy Peanut Butter: 76, medium confidence, point at the evidence badges and the Made in Canada tier. 3: Compare tab, Coffee: well-documented products first, limited-data products last. 4: Ask tab: Canadian, no plastic, fair labour, which coffee? 5: Nearby tab: stores and distances. 6: type the real barcode 3017620422003 for a live Open Food Facts lookup. Backup if the internet fails: everything except the live lookup runs locally.</a:t>
+              <a:t>Demo script. 1: Priorities tab, Buy Canadian preset, switch language to French. 2: Scan tab, search peanut, open Prairie Creamy Peanut Butter: 76, medium confidence, point at the evidence badges and the Made in Canada tier. 3: Compare tab, Coffee: well-documented products first, limited-data products last. 4: Ask tab: Canadian, no plastic, fair labour, which coffee? 5: Nearby tab: stores and distances. 6: type the real barcode 3017620422003 for a live Open Food Facts lookup. Backup if the internet fails: everything except the live lookup runs locally.</a:t>
             </a:r>
             <a:endParaRPr lang="en-US" dirty="0"/>
           </a:p>
@@ -8877,7 +8877,7 @@
                   <a:srgbClr val="14302A"/>
                 </a:solidFill>
               </a:rPr>
-              <a:t>3 languages</a:t>
+              <a:t>2 languages</a:t>
             </a:r>
             <a:endParaRPr lang="en-US" sz="2000" dirty="0"/>
           </a:p>
@@ -8913,7 +8913,7 @@
                   <a:srgbClr val="4A5A52"/>
                 </a:solidFill>
               </a:rPr>
-              <a:t>English · Français · ગુજરાતી</a:t>
+              <a:t>English · Français</a:t>
             </a:r>
             <a:endParaRPr lang="en-US" sz="1400" dirty="0"/>
           </a:p>

</xml_diff>

<commit_message>
Online demo on GitHub Pages: nachiket-96.github.io/truthshift
- localApi.js runs the scoring engine in the browser (same scores as the
  Python backend for all 118 products), so the demo needs no server
- npm run build:pages + deploy-pages.sh publish to the gh-pages branch
- Live link in the READMEs and on the last slide

Co-Authored-By: Claude Opus 5.5 <noreply@anthropic.com>
</commit_message>
<xml_diff>
--- a/presentation/TruthShift_Presentation.pptx
+++ b/presentation/TruthShift_Presentation.pptx
@@ -123,7 +123,7 @@
   <p:extLst>
     <p:ext uri="{521415D9-36F7-43E2-AB2F-B90AF26B5E84}">
       <p14:sectionLst xmlns:p14="http://schemas.microsoft.com/office/powerpoint/2010/main">
-        <p14:section name="Why" id="{1c19757a-9ba5-7c27-c035-7682ddb088bf}">
+        <p14:section name="Why" id="{49e7a824-0d1e-db74-5be4-2f044e6429a1}">
           <p14:sldIdLst>
             <p14:sldId id="256"/>
             <p14:sldId id="257"/>
@@ -131,38 +131,38 @@
             <p14:sldId id="259"/>
           </p14:sldIdLst>
         </p14:section>
-        <p14:section name="What it does" id="{8a0520d7-7c8c-61c6-05e2-7063c1cca5ab}">
+        <p14:section name="What it does" id="{ca56a1b8-ba1e-7165-800e-4d4d50dba6c3}">
           <p14:sldIdLst>
             <p14:sldId id="260"/>
             <p14:sldId id="261"/>
             <p14:sldId id="262"/>
           </p14:sldIdLst>
         </p14:section>
-        <p14:section name="Demo" id="{49bb6b26-2c9c-aba9-29b4-e6bd53750cdf}">
+        <p14:section name="Demo" id="{4ddbe197-7496-e2bc-95d8-34ac8d675d00}">
           <p14:sldIdLst>
             <p14:sldId id="263"/>
           </p14:sldIdLst>
         </p14:section>
-        <p14:section name="How it is built" id="{485f64da-2eea-6eec-5732-45305574c1bc}">
+        <p14:section name="How it is built" id="{bc8c771a-d425-6a76-ee97-0c21ddf851eb}">
           <p14:sldIdLst>
             <p14:sldId id="264"/>
             <p14:sldId id="267"/>
           </p14:sldIdLst>
         </p14:section>
-        <p14:section name="Model" id="{0584153e-3c12-3692-d00d-cff22e2ca714}">
+        <p14:section name="Model" id="{ce0965f5-07f6-41f4-fe53-eeb1de361b4e}">
           <p14:sldIdLst>
             <p14:sldId id="265"/>
             <p14:sldId id="266"/>
           </p14:sldIdLst>
         </p14:section>
-        <p14:section name="Business model" id="{6ca29899-0b31-16b8-3d35-b36a6fa7e48e}">
+        <p14:section name="Business model" id="{110ec468-a497-e61f-f0ad-d787c3f974e6}">
           <p14:sldIdLst>
             <p14:sldId id="268"/>
             <p14:sldId id="269"/>
             <p14:sldId id="270"/>
           </p14:sldIdLst>
         </p14:section>
-        <p14:section name="Next" id="{6db61215-8d6a-a367-b95f-6281565ceb9e}">
+        <p14:section name="Next" id="{d74a2829-3f0c-9788-3cf5-1852b1a22163}">
           <p14:sldIdLst>
             <p14:sldId id="271"/>
             <p14:sldId id="272"/>
@@ -2509,7 +2509,7 @@
           <a:p>
             <a:r>
               <a:rPr lang="en-US" dirty="0"/>
-              <a:t>Thank you. The code, this presentation and the documentation are on GitHub. We are happy to take questions, or let you try the app.</a:t>
+              <a:t>Thank you. Try TruthShift on your own phone at nachiket-96.github.io/truthshift. The code, this presentation and the documentation are on GitHub. We are happy to take questions, or let you try the app.</a:t>
             </a:r>
             <a:endParaRPr lang="en-US" dirty="0"/>
           </a:p>
@@ -8065,6 +8065,73 @@
                 </a:hlinkClick>
               </a:rPr>
               <a:t>github.com/Nachiket-96/truthshift</a:t>
+            </a:r>
+            <a:endParaRPr lang="en-US" sz="1800" dirty="0"/>
+          </a:p>
+        </p:txBody>
+      </p:sp>
+      <p:pic>
+        <p:nvPicPr>
+          <p:cNvPr id="6" name="demo-icon" descr="Live demo">    </p:cNvPr>
+          <p:cNvPicPr>
+            <a:picLocks noChangeAspect="1"/>
+          </p:cNvPicPr>
+          <p:nvPr/>
+        </p:nvPicPr>
+        <p:blipFill>
+          <a:blip r:embed="rId3"/>
+          <a:stretch>
+            <a:fillRect/>
+          </a:stretch>
+        </p:blipFill>
+        <p:spPr>
+          <a:xfrm>
+            <a:off x="548640" y="3977640"/>
+            <a:ext cx="411480" cy="411480"/>
+          </a:xfrm>
+          <a:prstGeom prst="rect">
+            <a:avLst/>
+          </a:prstGeom>
+        </p:spPr>
+      </p:pic>
+      <p:sp>
+        <p:nvSpPr>
+          <p:cNvPr id="7" name="Text 3"/>
+          <p:cNvSpPr txBox="1"/>
+          <p:nvPr/>
+        </p:nvSpPr>
+        <p:spPr>
+          <a:xfrm>
+            <a:off x="1097280" y="3977640"/>
+            <a:ext cx="5486400" cy="411480"/>
+          </a:xfrm>
+          <a:prstGeom prst="rect">
+            <a:avLst/>
+          </a:prstGeom>
+          <a:noFill/>
+          <a:ln/>
+        </p:spPr>
+        <p:txBody>
+          <a:bodyPr wrap="square" lIns="0" tIns="0" rIns="0" bIns="0" rtlCol="0" anchor="ctr"/>
+          <a:lstStyle/>
+          <a:p>
+            <a:pPr indent="0" marL="0">
+              <a:buNone/>
+            </a:pPr>
+            <a:r>
+              <a:rPr lang="en-US" sz="1800" u="sng" dirty="0">
+                <a:solidFill>
+                  <a:srgbClr val="8FD4AE"/>
+                </a:solidFill>
+                <a:hlinkClick r:id="rId4" invalidUrl="" action="" tgtFrame="" tooltip="" history="1" highlightClick="0" endSnd="0">
+                  <a:extLst>
+                    <a:ext uri="{A12FA001-AC4F-418D-AE19-62706E023703}">
+                      <ahyp:hlinkClr xmlns:ahyp="http://schemas.microsoft.com/office/drawing/2018/hyperlinkcolor" val="tx"/>
+                    </a:ext>
+                  </a:extLst>
+                </a:hlinkClick>
+              </a:rPr>
+              <a:t>nachiket-96.github.io/truthshift</a:t>
             </a:r>
             <a:endParaRPr lang="en-US" sz="1800" dirty="0"/>
           </a:p>

</xml_diff>